<commit_message>
docs(presentation): Update takeaways and add Code Agent pitfalls slide
Refined the 'Takeaways' section on Slide 09 and introduced a new slide detailing common pitfalls when using Code Agents.

The 'Takeaways' section was updated to provide a more comprehensive and current understanding of the agentic system's core principles, including the ReAct loop, tool design philosophy, isolation mechanisms, permission layers, and the importance of verification via JSONL.

A new slide (Slide 24) was added to address the practical challenges and 'traps' of using Code Agents. This slide outlines situations where agent usage might be counterproductive (e.g., high communication cost, vague tasks) and provides strategies to mitigate these issues, ensuring agents are used effectively.

The `claude_code_full.pptx` binary file was updated to reflect these content changes.
</commit_message>
<xml_diff>
--- a/claude_code_full.pptx
+++ b/claude_code_full.pptx
@@ -29,6 +29,7 @@
     <p:sldId id="277" r:id="rId28"/>
     <p:sldId id="278" r:id="rId29"/>
     <p:sldId id="279" r:id="rId30"/>
+    <p:sldId id="280" r:id="rId31"/>
   </p:sldIdLst>
   <p:sldSz cx="12188952" cy="6858000" type="screen4x3"/>
   <p:notesSz cx="6858000" cy="9144000"/>
@@ -23607,7 +23608,7 @@
                   <a:srgbClr val="1D6FC8"/>
                 </a:solidFill>
               </a:rPr>
-              <a:t>Agentic Loop</a:t>
+              <a:t>不是工具包，是系統</a:t>
             </a:r>
           </a:p>
         </p:txBody>
@@ -23641,7 +23642,7 @@
                   <a:srgbClr val="1A222E"/>
                 </a:solidFill>
               </a:rPr>
-              <a:t>批次 tool call 平行執行，不含 tool_use 才停止。Subagent 有獨立 loop，不佔主 agent 的推理次數。</a:t>
+              <a:t>四個 Reason 互相依賴：Tools 讓 Loop 落地，Loop 讓 Context 有意義，Context 讓長任務品質撐住，Model 決定每一步推理上限。缺一個，系統降級。</a:t>
             </a:r>
           </a:p>
         </p:txBody>
@@ -23718,7 +23719,7 @@
                   <a:srgbClr val="057A50"/>
                 </a:solidFill>
               </a:rPr>
-              <a:t>工具設計哲學</a:t>
+              <a:t>Loop 的底層就是 ReAct</a:t>
             </a:r>
           </a:p>
         </p:txBody>
@@ -23752,7 +23753,7 @@
                   <a:srgbClr val="1A222E"/>
                 </a:solidFill>
               </a:rPr>
-              <a:t>讀取工具預載且 auto-allow → 零中斷探索。Edit 只傳 diff → token 最少。每個工具針對最少確認次數最佳化。</a:t>
+              <a:t>每一步 = Reason → tool_use → tool_result，批次平行發出，不含 tool_use 才終止。Subagent 有獨立 loop，context 不互污。</a:t>
             </a:r>
           </a:p>
         </p:txBody>
@@ -23829,7 +23830,7 @@
                   <a:srgbClr val="B45A00"/>
                 </a:solidFill>
               </a:rPr>
-              <a:t>Pre-loaded vs Deferred</a:t>
+              <a:t>工具設計原則：保護 loop 流暢度</a:t>
             </a:r>
           </a:p>
         </p:txBody>
@@ -23863,7 +23864,7 @@
                   <a:srgbClr val="1A222E"/>
                 </a:solidFill>
               </a:rPr>
-              <a:t>9 個預載（零延遲）vs 17 個延遲載入（省 token，透過 ToolSearch，+2-3 秒）。根據使用頻率權衡 latency 與 token budget。</a:t>
+              <a:t>唯讀工具 auto-allow + 預載 → 探索零中斷。Edit 只傳 diff → token 最省。每個設計決策都在降低確認摩擦。</a:t>
             </a:r>
           </a:p>
         </p:txBody>
@@ -23940,7 +23941,7 @@
                   <a:srgbClr val="5B21B6"/>
                 </a:solidFill>
               </a:rPr>
-              <a:t>Skill &amp; Agent 的隔離差異</a:t>
+              <a:t>隔離有兩種強度，用途不同</a:t>
             </a:r>
           </a:p>
         </p:txBody>
@@ -23974,7 +23975,7 @@
                   <a:srgbClr val="1A222E"/>
                 </a:solidFill>
               </a:rPr>
-              <a:t>Skill allowed-tools 是軟性（context 共享）。Agent tools 是硬性 API 層隔離（LLM 根本看不到其他工具 schema）。</a:t>
+              <a:t>Skill allowed-tools = 軟性（LLM 仍可呼叫其他工具）。Agent tools = 硬性 API 層隔離（LLM 根本看不到白名單以外的 schema）。不能互換。</a:t>
             </a:r>
           </a:p>
         </p:txBody>
@@ -24051,7 +24052,7 @@
                   <a:srgbClr val="AA1818"/>
                 </a:solidFill>
               </a:rPr>
-              <a:t>Permission 安全設計</a:t>
+              <a:t>Permission 有兩層，只有一層能設定</a:t>
             </a:r>
           </a:p>
         </p:txBody>
@@ -24085,7 +24086,7 @@
                   <a:srgbClr val="1A222E"/>
                 </a:solidFill>
               </a:rPr>
-              <a:t>複合命令永遠不匹配 prefix 規則（binary 逆向確認）。Layer 2 判斷性確認無法用設定關閉。</a:t>
+              <a:t>Framework 規則（auto-allow / Plan Mode / settings.json）可設定。Claude 的訓練習慣（發現非預期狀態就暫停確認）無法透過任何設定改變，因為改的是 framework，不是 model。</a:t>
             </a:r>
           </a:p>
         </p:txBody>
@@ -24159,10 +24160,10 @@
             <a:r>
               <a:rPr sz="1700" b="1" i="0">
                 <a:solidFill>
-                  <a:srgbClr val="55657A"/>
-                </a:solidFill>
-              </a:rPr>
-              <a:t>Strong Model 貫穿始終</a:t>
+                  <a:srgbClr val="0E7A8E"/>
+                </a:solidFill>
+              </a:rPr>
+              <a:t>各環節良率決定整體成功率</a:t>
             </a:r>
           </a:p>
         </p:txBody>
@@ -24196,7 +24197,7 @@
                   <a:srgbClr val="1A222E"/>
                 </a:solidFill>
               </a:rPr>
-              <a:t>前面每一個機制能正確運作，背後都是 model 在每一步做出正確判斷。工具再多，model 推理錯誤，整個系統就跑偏。</a:t>
+              <a:t>Agentic loop 的成功率是各環節的乘積：理解需求、選對工具、解讀結果、判斷下一步，每一步都必須正確。就像晶圓製造，單步良率的微小差距，在數十輪迭代後會被放大成巨大的整體差距。這也是 Strong Model 為何如此關鍵。</a:t>
             </a:r>
           </a:p>
         </p:txBody>
@@ -24210,6 +24211,117 @@
         <p:spPr>
           <a:xfrm>
             <a:off x="457200" y="5669280"/>
+            <a:ext cx="11274552" cy="41148"/>
+          </a:xfrm>
+          <a:prstGeom prst="rect">
+            <a:avLst/>
+          </a:prstGeom>
+          <a:solidFill>
+            <a:srgbClr val="E2E8F0"/>
+          </a:solidFill>
+          <a:ln>
+            <a:noFill/>
+          </a:ln>
+        </p:spPr>
+        <p:style>
+          <a:lnRef idx="1">
+            <a:schemeClr val="accent1"/>
+          </a:lnRef>
+          <a:fillRef idx="3">
+            <a:schemeClr val="accent1"/>
+          </a:fillRef>
+          <a:effectRef idx="2">
+            <a:schemeClr val="accent1"/>
+          </a:effectRef>
+          <a:fontRef idx="minor">
+            <a:schemeClr val="lt1"/>
+          </a:fontRef>
+        </p:style>
+        <p:txBody>
+          <a:bodyPr rtlCol="0" anchor="ctr"/>
+          <a:lstStyle/>
+          <a:p>
+            <a:pPr algn="ctr"/>
+          </a:p>
+        </p:txBody>
+      </p:sp>
+      <p:sp>
+        <p:nvSpPr>
+          <p:cNvPr id="24" name="TextBox 23"/>
+          <p:cNvSpPr txBox="1"/>
+          <p:nvPr/>
+        </p:nvSpPr>
+        <p:spPr>
+          <a:xfrm>
+            <a:off x="502920" y="5760720"/>
+            <a:ext cx="2377440" cy="438912"/>
+          </a:xfrm>
+          <a:prstGeom prst="rect">
+            <a:avLst/>
+          </a:prstGeom>
+          <a:noFill/>
+        </p:spPr>
+        <p:txBody>
+          <a:bodyPr wrap="square">
+            <a:spAutoFit/>
+          </a:bodyPr>
+          <a:lstStyle/>
+          <a:p>
+            <a:pPr algn="l"/>
+            <a:r>
+              <a:rPr sz="1700" b="1" i="0">
+                <a:solidFill>
+                  <a:srgbClr val="55657A"/>
+                </a:solidFill>
+              </a:rPr>
+              <a:t>行為要靠 JSONL 驗證</a:t>
+            </a:r>
+          </a:p>
+        </p:txBody>
+      </p:sp>
+      <p:sp>
+        <p:nvSpPr>
+          <p:cNvPr id="25" name="TextBox 24"/>
+          <p:cNvSpPr txBox="1"/>
+          <p:nvPr/>
+        </p:nvSpPr>
+        <p:spPr>
+          <a:xfrm>
+            <a:off x="2971800" y="5760720"/>
+            <a:ext cx="8732520" cy="502920"/>
+          </a:xfrm>
+          <a:prstGeom prst="rect">
+            <a:avLst/>
+          </a:prstGeom>
+          <a:noFill/>
+        </p:spPr>
+        <p:txBody>
+          <a:bodyPr wrap="square">
+            <a:spAutoFit/>
+          </a:bodyPr>
+          <a:lstStyle/>
+          <a:p>
+            <a:pPr algn="l"/>
+            <a:r>
+              <a:rPr sz="1600" b="0" i="0">
+                <a:solidFill>
+                  <a:srgbClr val="1A222E"/>
+                </a:solidFill>
+              </a:rPr>
+              <a:t>文件說設計意圖，JSONL 說實際行為。本簡報所有機制描述都以 session JSONL 交叉驗證，兩者有時不同，以 JSONL 為準。</a:t>
+            </a:r>
+          </a:p>
+        </p:txBody>
+      </p:sp>
+      <p:sp>
+        <p:nvSpPr>
+          <p:cNvPr id="26" name="Rectangle 25"/>
+          <p:cNvSpPr/>
+          <p:nvPr/>
+        </p:nvSpPr>
+        <p:spPr>
+          <a:xfrm>
+            <a:off x="457200" y="6419088"/>
             <a:ext cx="11274552" cy="41148"/>
           </a:xfrm>
           <a:prstGeom prst="rect">
@@ -24253,6 +24365,809 @@
 </file>
 
 <file path=ppt/slides/slide24.xml><?xml version="1.0" encoding="utf-8"?>
+<p:sld xmlns:a="http://schemas.openxmlformats.org/drawingml/2006/main" xmlns:p="http://schemas.openxmlformats.org/presentationml/2006/main" xmlns:r="http://schemas.openxmlformats.org/officeDocument/2006/relationships">
+  <p:cSld>
+    <p:bg>
+      <p:bgPr>
+        <a:solidFill>
+          <a:srgbClr val="FFFFFF"/>
+        </a:solidFill>
+        <a:effectLst/>
+      </p:bgPr>
+    </p:bg>
+    <p:spTree>
+      <p:nvGrpSpPr>
+        <p:cNvPr id="1" name=""/>
+        <p:cNvGrpSpPr/>
+        <p:nvPr/>
+      </p:nvGrpSpPr>
+      <p:grpSpPr/>
+      <p:sp>
+        <p:nvSpPr>
+          <p:cNvPr id="2" name="Rectangle 1"/>
+          <p:cNvSpPr/>
+          <p:nvPr/>
+        </p:nvSpPr>
+        <p:spPr>
+          <a:xfrm>
+            <a:off x="0" y="0"/>
+            <a:ext cx="12188952" cy="91440"/>
+          </a:xfrm>
+          <a:prstGeom prst="rect">
+            <a:avLst/>
+          </a:prstGeom>
+          <a:solidFill>
+            <a:srgbClr val="1D6FC8"/>
+          </a:solidFill>
+          <a:ln>
+            <a:noFill/>
+          </a:ln>
+        </p:spPr>
+        <p:style>
+          <a:lnRef idx="1">
+            <a:schemeClr val="accent1"/>
+          </a:lnRef>
+          <a:fillRef idx="3">
+            <a:schemeClr val="accent1"/>
+          </a:fillRef>
+          <a:effectRef idx="2">
+            <a:schemeClr val="accent1"/>
+          </a:effectRef>
+          <a:fontRef idx="minor">
+            <a:schemeClr val="lt1"/>
+          </a:fontRef>
+        </p:style>
+        <p:txBody>
+          <a:bodyPr rtlCol="0" anchor="ctr"/>
+          <a:lstStyle/>
+          <a:p>
+            <a:pPr algn="ctr"/>
+          </a:p>
+        </p:txBody>
+      </p:sp>
+      <p:sp>
+        <p:nvSpPr>
+          <p:cNvPr id="3" name="TextBox 2"/>
+          <p:cNvSpPr txBox="1"/>
+          <p:nvPr/>
+        </p:nvSpPr>
+        <p:spPr>
+          <a:xfrm>
+            <a:off x="502920" y="146304"/>
+            <a:ext cx="11155680" cy="475488"/>
+          </a:xfrm>
+          <a:prstGeom prst="rect">
+            <a:avLst/>
+          </a:prstGeom>
+          <a:noFill/>
+        </p:spPr>
+        <p:txBody>
+          <a:bodyPr wrap="square">
+            <a:spAutoFit/>
+          </a:bodyPr>
+          <a:lstStyle/>
+          <a:p>
+            <a:pPr algn="l"/>
+            <a:r>
+              <a:rPr sz="2400" b="1" i="0">
+                <a:solidFill>
+                  <a:srgbClr val="1A222E"/>
+                </a:solidFill>
+              </a:rPr>
+              <a:t>補充：使用 Code Agent 最大的陷阱</a:t>
+            </a:r>
+          </a:p>
+        </p:txBody>
+      </p:sp>
+      <p:sp>
+        <p:nvSpPr>
+          <p:cNvPr id="4" name="TextBox 3"/>
+          <p:cNvSpPr txBox="1"/>
+          <p:nvPr/>
+        </p:nvSpPr>
+        <p:spPr>
+          <a:xfrm>
+            <a:off x="502920" y="640080"/>
+            <a:ext cx="11155680" cy="274320"/>
+          </a:xfrm>
+          <a:prstGeom prst="rect">
+            <a:avLst/>
+          </a:prstGeom>
+          <a:noFill/>
+        </p:spPr>
+        <p:txBody>
+          <a:bodyPr wrap="square">
+            <a:spAutoFit/>
+          </a:bodyPr>
+          <a:lstStyle/>
+          <a:p>
+            <a:pPr algn="l"/>
+            <a:r>
+              <a:rPr sz="1300" b="0" i="1">
+                <a:solidFill>
+                  <a:srgbClr val="55657A"/>
+                </a:solidFill>
+              </a:rPr>
+              <a:t>當溝通 + 修正 + 審查的成本 &gt; 自己寫的成本，用 Agent 反而更慢</a:t>
+            </a:r>
+          </a:p>
+        </p:txBody>
+      </p:sp>
+      <p:sp>
+        <p:nvSpPr>
+          <p:cNvPr id="5" name="Rectangle 4"/>
+          <p:cNvSpPr/>
+          <p:nvPr/>
+        </p:nvSpPr>
+        <p:spPr>
+          <a:xfrm>
+            <a:off x="457200" y="950976"/>
+            <a:ext cx="11274552" cy="41148"/>
+          </a:xfrm>
+          <a:prstGeom prst="rect">
+            <a:avLst/>
+          </a:prstGeom>
+          <a:solidFill>
+            <a:srgbClr val="E2E8F0"/>
+          </a:solidFill>
+          <a:ln>
+            <a:noFill/>
+          </a:ln>
+        </p:spPr>
+        <p:style>
+          <a:lnRef idx="1">
+            <a:schemeClr val="accent1"/>
+          </a:lnRef>
+          <a:fillRef idx="3">
+            <a:schemeClr val="accent1"/>
+          </a:fillRef>
+          <a:effectRef idx="2">
+            <a:schemeClr val="accent1"/>
+          </a:effectRef>
+          <a:fontRef idx="minor">
+            <a:schemeClr val="lt1"/>
+          </a:fontRef>
+        </p:style>
+        <p:txBody>
+          <a:bodyPr rtlCol="0" anchor="ctr"/>
+          <a:lstStyle/>
+          <a:p>
+            <a:pPr algn="ctr"/>
+          </a:p>
+        </p:txBody>
+      </p:sp>
+      <p:sp>
+        <p:nvSpPr>
+          <p:cNvPr id="6" name="Rectangle 5"/>
+          <p:cNvSpPr/>
+          <p:nvPr/>
+        </p:nvSpPr>
+        <p:spPr>
+          <a:xfrm>
+            <a:off x="457200" y="1051560"/>
+            <a:ext cx="11274552" cy="475488"/>
+          </a:xfrm>
+          <a:prstGeom prst="rect">
+            <a:avLst/>
+          </a:prstGeom>
+          <a:solidFill>
+            <a:srgbClr val="AA1818"/>
+          </a:solidFill>
+          <a:ln>
+            <a:noFill/>
+          </a:ln>
+        </p:spPr>
+        <p:style>
+          <a:lnRef idx="1">
+            <a:schemeClr val="accent1"/>
+          </a:lnRef>
+          <a:fillRef idx="3">
+            <a:schemeClr val="accent1"/>
+          </a:fillRef>
+          <a:effectRef idx="2">
+            <a:schemeClr val="accent1"/>
+          </a:effectRef>
+          <a:fontRef idx="minor">
+            <a:schemeClr val="lt1"/>
+          </a:fontRef>
+        </p:style>
+        <p:txBody>
+          <a:bodyPr rtlCol="0" anchor="ctr"/>
+          <a:lstStyle/>
+          <a:p>
+            <a:pPr algn="ctr"/>
+          </a:p>
+        </p:txBody>
+      </p:sp>
+      <p:sp>
+        <p:nvSpPr>
+          <p:cNvPr id="7" name="TextBox 6"/>
+          <p:cNvSpPr txBox="1"/>
+          <p:nvPr/>
+        </p:nvSpPr>
+        <p:spPr>
+          <a:xfrm>
+            <a:off x="621792" y="1115568"/>
+            <a:ext cx="10972800" cy="329184"/>
+          </a:xfrm>
+          <a:prstGeom prst="rect">
+            <a:avLst/>
+          </a:prstGeom>
+          <a:noFill/>
+        </p:spPr>
+        <p:txBody>
+          <a:bodyPr wrap="square">
+            <a:spAutoFit/>
+          </a:bodyPr>
+          <a:lstStyle/>
+          <a:p>
+            <a:pPr algn="l"/>
+            <a:r>
+              <a:rPr sz="1600" b="1" i="0">
+                <a:solidFill>
+                  <a:srgbClr val="FFFFFF"/>
+                </a:solidFill>
+              </a:rPr>
+              <a:t>溝通成本 &gt; 實作成本  →  用 Agent 反而比自己寫更花時間</a:t>
+            </a:r>
+          </a:p>
+        </p:txBody>
+      </p:sp>
+      <p:sp>
+        <p:nvSpPr>
+          <p:cNvPr id="8" name="Rectangle 7"/>
+          <p:cNvSpPr/>
+          <p:nvPr/>
+        </p:nvSpPr>
+        <p:spPr>
+          <a:xfrm>
+            <a:off x="457200" y="1600200"/>
+            <a:ext cx="5394960" cy="310896"/>
+          </a:xfrm>
+          <a:prstGeom prst="rect">
+            <a:avLst/>
+          </a:prstGeom>
+          <a:solidFill>
+            <a:srgbClr val="B45A00"/>
+          </a:solidFill>
+          <a:ln>
+            <a:noFill/>
+          </a:ln>
+        </p:spPr>
+        <p:style>
+          <a:lnRef idx="1">
+            <a:schemeClr val="accent1"/>
+          </a:lnRef>
+          <a:fillRef idx="3">
+            <a:schemeClr val="accent1"/>
+          </a:fillRef>
+          <a:effectRef idx="2">
+            <a:schemeClr val="accent1"/>
+          </a:effectRef>
+          <a:fontRef idx="minor">
+            <a:schemeClr val="lt1"/>
+          </a:fontRef>
+        </p:style>
+        <p:txBody>
+          <a:bodyPr rtlCol="0" anchor="ctr"/>
+          <a:lstStyle/>
+          <a:p>
+            <a:pPr algn="ctr"/>
+          </a:p>
+        </p:txBody>
+      </p:sp>
+      <p:sp>
+        <p:nvSpPr>
+          <p:cNvPr id="9" name="TextBox 8"/>
+          <p:cNvSpPr txBox="1"/>
+          <p:nvPr/>
+        </p:nvSpPr>
+        <p:spPr>
+          <a:xfrm>
+            <a:off x="594360" y="1627632"/>
+            <a:ext cx="5120640" cy="237744"/>
+          </a:xfrm>
+          <a:prstGeom prst="rect">
+            <a:avLst/>
+          </a:prstGeom>
+          <a:noFill/>
+        </p:spPr>
+        <p:txBody>
+          <a:bodyPr wrap="square">
+            <a:spAutoFit/>
+          </a:bodyPr>
+          <a:lstStyle/>
+          <a:p>
+            <a:pPr algn="l"/>
+            <a:r>
+              <a:rPr sz="1300" b="1" i="0">
+                <a:solidFill>
+                  <a:srgbClr val="FFFFFF"/>
+                </a:solidFill>
+              </a:rPr>
+              <a:t>什麼時候容易踩到</a:t>
+            </a:r>
+          </a:p>
+        </p:txBody>
+      </p:sp>
+      <p:sp>
+        <p:nvSpPr>
+          <p:cNvPr id="10" name="TextBox 9"/>
+          <p:cNvSpPr txBox="1"/>
+          <p:nvPr/>
+        </p:nvSpPr>
+        <p:spPr>
+          <a:xfrm>
+            <a:off x="594360" y="1938528"/>
+            <a:ext cx="5166360" cy="384048"/>
+          </a:xfrm>
+          <a:prstGeom prst="rect">
+            <a:avLst/>
+          </a:prstGeom>
+          <a:noFill/>
+        </p:spPr>
+        <p:txBody>
+          <a:bodyPr wrap="square">
+            <a:spAutoFit/>
+          </a:bodyPr>
+          <a:lstStyle/>
+          <a:p>
+            <a:pPr algn="l"/>
+            <a:r>
+              <a:rPr sz="1300" b="0" i="0">
+                <a:solidFill>
+                  <a:srgbClr val="1A222E"/>
+                </a:solidFill>
+              </a:rPr>
+              <a:t>• 任務邊界模糊：Agent 猜錯方向，做完才發現不是你要的</a:t>
+            </a:r>
+          </a:p>
+        </p:txBody>
+      </p:sp>
+      <p:sp>
+        <p:nvSpPr>
+          <p:cNvPr id="11" name="TextBox 10"/>
+          <p:cNvSpPr txBox="1"/>
+          <p:nvPr/>
+        </p:nvSpPr>
+        <p:spPr>
+          <a:xfrm>
+            <a:off x="594360" y="2340864"/>
+            <a:ext cx="5166360" cy="384048"/>
+          </a:xfrm>
+          <a:prstGeom prst="rect">
+            <a:avLst/>
+          </a:prstGeom>
+          <a:noFill/>
+        </p:spPr>
+        <p:txBody>
+          <a:bodyPr wrap="square">
+            <a:spAutoFit/>
+          </a:bodyPr>
+          <a:lstStyle/>
+          <a:p>
+            <a:pPr algn="l"/>
+            <a:r>
+              <a:rPr sz="1300" b="0" i="0">
+                <a:solidFill>
+                  <a:srgbClr val="1A222E"/>
+                </a:solidFill>
+              </a:rPr>
+              <a:t>• 任務太大、無中間驗證點：跑完 30 步後才發現第 3 步就偏了</a:t>
+            </a:r>
+          </a:p>
+        </p:txBody>
+      </p:sp>
+      <p:sp>
+        <p:nvSpPr>
+          <p:cNvPr id="12" name="TextBox 11"/>
+          <p:cNvSpPr txBox="1"/>
+          <p:nvPr/>
+        </p:nvSpPr>
+        <p:spPr>
+          <a:xfrm>
+            <a:off x="594360" y="2743200"/>
+            <a:ext cx="5166360" cy="384048"/>
+          </a:xfrm>
+          <a:prstGeom prst="rect">
+            <a:avLst/>
+          </a:prstGeom>
+          <a:noFill/>
+        </p:spPr>
+        <p:txBody>
+          <a:bodyPr wrap="square">
+            <a:spAutoFit/>
+          </a:bodyPr>
+          <a:lstStyle/>
+          <a:p>
+            <a:pPr algn="l"/>
+            <a:r>
+              <a:rPr sz="1300" b="0" i="0">
+                <a:solidFill>
+                  <a:srgbClr val="1A222E"/>
+                </a:solidFill>
+              </a:rPr>
+              <a:t>• 缺少 domain context：不知道你的慣例、架構決策、命名規範</a:t>
+            </a:r>
+          </a:p>
+        </p:txBody>
+      </p:sp>
+      <p:sp>
+        <p:nvSpPr>
+          <p:cNvPr id="13" name="TextBox 12"/>
+          <p:cNvSpPr txBox="1"/>
+          <p:nvPr/>
+        </p:nvSpPr>
+        <p:spPr>
+          <a:xfrm>
+            <a:off x="594360" y="3145536"/>
+            <a:ext cx="5166360" cy="384048"/>
+          </a:xfrm>
+          <a:prstGeom prst="rect">
+            <a:avLst/>
+          </a:prstGeom>
+          <a:noFill/>
+        </p:spPr>
+        <p:txBody>
+          <a:bodyPr wrap="square">
+            <a:spAutoFit/>
+          </a:bodyPr>
+          <a:lstStyle/>
+          <a:p>
+            <a:pPr algn="l"/>
+            <a:r>
+              <a:rPr sz="1300" b="0" i="0">
+                <a:solidFill>
+                  <a:srgbClr val="1A222E"/>
+                </a:solidFill>
+              </a:rPr>
+              <a:t>• 輸出難以驗證：沒有 test / lint，只能人眼審查，成本高</a:t>
+            </a:r>
+          </a:p>
+        </p:txBody>
+      </p:sp>
+      <p:sp>
+        <p:nvSpPr>
+          <p:cNvPr id="14" name="Rectangle 13"/>
+          <p:cNvSpPr/>
+          <p:nvPr/>
+        </p:nvSpPr>
+        <p:spPr>
+          <a:xfrm>
+            <a:off x="6336792" y="1600200"/>
+            <a:ext cx="5394960" cy="310896"/>
+          </a:xfrm>
+          <a:prstGeom prst="rect">
+            <a:avLst/>
+          </a:prstGeom>
+          <a:solidFill>
+            <a:srgbClr val="057A50"/>
+          </a:solidFill>
+          <a:ln>
+            <a:noFill/>
+          </a:ln>
+        </p:spPr>
+        <p:style>
+          <a:lnRef idx="1">
+            <a:schemeClr val="accent1"/>
+          </a:lnRef>
+          <a:fillRef idx="3">
+            <a:schemeClr val="accent1"/>
+          </a:fillRef>
+          <a:effectRef idx="2">
+            <a:schemeClr val="accent1"/>
+          </a:effectRef>
+          <a:fontRef idx="minor">
+            <a:schemeClr val="lt1"/>
+          </a:fontRef>
+        </p:style>
+        <p:txBody>
+          <a:bodyPr rtlCol="0" anchor="ctr"/>
+          <a:lstStyle/>
+          <a:p>
+            <a:pPr algn="ctr"/>
+          </a:p>
+        </p:txBody>
+      </p:sp>
+      <p:sp>
+        <p:nvSpPr>
+          <p:cNvPr id="15" name="TextBox 14"/>
+          <p:cNvSpPr txBox="1"/>
+          <p:nvPr/>
+        </p:nvSpPr>
+        <p:spPr>
+          <a:xfrm>
+            <a:off x="6473952" y="1627632"/>
+            <a:ext cx="5120640" cy="237744"/>
+          </a:xfrm>
+          <a:prstGeom prst="rect">
+            <a:avLst/>
+          </a:prstGeom>
+          <a:noFill/>
+        </p:spPr>
+        <p:txBody>
+          <a:bodyPr wrap="square">
+            <a:spAutoFit/>
+          </a:bodyPr>
+          <a:lstStyle/>
+          <a:p>
+            <a:pPr algn="l"/>
+            <a:r>
+              <a:rPr sz="1300" b="1" i="0">
+                <a:solidFill>
+                  <a:srgbClr val="FFFFFF"/>
+                </a:solidFill>
+              </a:rPr>
+              <a:t>怎麼讓溝通成本 &lt; 實作成本</a:t>
+            </a:r>
+          </a:p>
+        </p:txBody>
+      </p:sp>
+      <p:sp>
+        <p:nvSpPr>
+          <p:cNvPr id="16" name="TextBox 15"/>
+          <p:cNvSpPr txBox="1"/>
+          <p:nvPr/>
+        </p:nvSpPr>
+        <p:spPr>
+          <a:xfrm>
+            <a:off x="6473952" y="1938528"/>
+            <a:ext cx="5166360" cy="384048"/>
+          </a:xfrm>
+          <a:prstGeom prst="rect">
+            <a:avLst/>
+          </a:prstGeom>
+          <a:noFill/>
+        </p:spPr>
+        <p:txBody>
+          <a:bodyPr wrap="square">
+            <a:spAutoFit/>
+          </a:bodyPr>
+          <a:lstStyle/>
+          <a:p>
+            <a:pPr algn="l"/>
+            <a:r>
+              <a:rPr sz="1300" b="0" i="0">
+                <a:solidFill>
+                  <a:srgbClr val="1A222E"/>
+                </a:solidFill>
+              </a:rPr>
+              <a:t>• 任務要有明確完成條件：描述結果，不是描述方向</a:t>
+            </a:r>
+          </a:p>
+        </p:txBody>
+      </p:sp>
+      <p:sp>
+        <p:nvSpPr>
+          <p:cNvPr id="17" name="TextBox 16"/>
+          <p:cNvSpPr txBox="1"/>
+          <p:nvPr/>
+        </p:nvSpPr>
+        <p:spPr>
+          <a:xfrm>
+            <a:off x="6473952" y="2340864"/>
+            <a:ext cx="5166360" cy="384048"/>
+          </a:xfrm>
+          <a:prstGeom prst="rect">
+            <a:avLst/>
+          </a:prstGeom>
+          <a:noFill/>
+        </p:spPr>
+        <p:txBody>
+          <a:bodyPr wrap="square">
+            <a:spAutoFit/>
+          </a:bodyPr>
+          <a:lstStyle/>
+          <a:p>
+            <a:pPr algn="l"/>
+            <a:r>
+              <a:rPr sz="1300" b="0" i="0">
+                <a:solidFill>
+                  <a:srgbClr val="1A222E"/>
+                </a:solidFill>
+              </a:rPr>
+              <a:t>• 小步驟迭代：每一輪確認方向正確再繼續，不要一次丟大任務</a:t>
+            </a:r>
+          </a:p>
+        </p:txBody>
+      </p:sp>
+      <p:sp>
+        <p:nvSpPr>
+          <p:cNvPr id="18" name="TextBox 17"/>
+          <p:cNvSpPr txBox="1"/>
+          <p:nvPr/>
+        </p:nvSpPr>
+        <p:spPr>
+          <a:xfrm>
+            <a:off x="6473952" y="2743200"/>
+            <a:ext cx="5166360" cy="384048"/>
+          </a:xfrm>
+          <a:prstGeom prst="rect">
+            <a:avLst/>
+          </a:prstGeom>
+          <a:noFill/>
+        </p:spPr>
+        <p:txBody>
+          <a:bodyPr wrap="square">
+            <a:spAutoFit/>
+          </a:bodyPr>
+          <a:lstStyle/>
+          <a:p>
+            <a:pPr algn="l"/>
+            <a:r>
+              <a:rPr sz="1300" b="0" i="0">
+                <a:solidFill>
+                  <a:srgbClr val="1A222E"/>
+                </a:solidFill>
+              </a:rPr>
+              <a:t>• 前置 context：CLAUDE.md、範例、架構說明先給好，不要讓 Agent 猜</a:t>
+            </a:r>
+          </a:p>
+        </p:txBody>
+      </p:sp>
+      <p:sp>
+        <p:nvSpPr>
+          <p:cNvPr id="19" name="TextBox 18"/>
+          <p:cNvSpPr txBox="1"/>
+          <p:nvPr/>
+        </p:nvSpPr>
+        <p:spPr>
+          <a:xfrm>
+            <a:off x="6473952" y="3145536"/>
+            <a:ext cx="5166360" cy="384048"/>
+          </a:xfrm>
+          <a:prstGeom prst="rect">
+            <a:avLst/>
+          </a:prstGeom>
+          <a:noFill/>
+        </p:spPr>
+        <p:txBody>
+          <a:bodyPr wrap="square">
+            <a:spAutoFit/>
+          </a:bodyPr>
+          <a:lstStyle/>
+          <a:p>
+            <a:pPr algn="l"/>
+            <a:r>
+              <a:rPr sz="1300" b="0" i="0">
+                <a:solidFill>
+                  <a:srgbClr val="1A222E"/>
+                </a:solidFill>
+              </a:rPr>
+              <a:t>• 有驗證機制：能跑測試才能自我修正；不能驗證的風險轉嫁給你</a:t>
+            </a:r>
+          </a:p>
+        </p:txBody>
+      </p:sp>
+      <p:sp>
+        <p:nvSpPr>
+          <p:cNvPr id="20" name="Rectangle 19"/>
+          <p:cNvSpPr/>
+          <p:nvPr/>
+        </p:nvSpPr>
+        <p:spPr>
+          <a:xfrm>
+            <a:off x="457200" y="3639312"/>
+            <a:ext cx="11274552" cy="41148"/>
+          </a:xfrm>
+          <a:prstGeom prst="rect">
+            <a:avLst/>
+          </a:prstGeom>
+          <a:solidFill>
+            <a:srgbClr val="E2E8F0"/>
+          </a:solidFill>
+          <a:ln>
+            <a:noFill/>
+          </a:ln>
+        </p:spPr>
+        <p:style>
+          <a:lnRef idx="1">
+            <a:schemeClr val="accent1"/>
+          </a:lnRef>
+          <a:fillRef idx="3">
+            <a:schemeClr val="accent1"/>
+          </a:fillRef>
+          <a:effectRef idx="2">
+            <a:schemeClr val="accent1"/>
+          </a:effectRef>
+          <a:fontRef idx="minor">
+            <a:schemeClr val="lt1"/>
+          </a:fontRef>
+        </p:style>
+        <p:txBody>
+          <a:bodyPr rtlCol="0" anchor="ctr"/>
+          <a:lstStyle/>
+          <a:p>
+            <a:pPr algn="ctr"/>
+          </a:p>
+        </p:txBody>
+      </p:sp>
+      <p:sp>
+        <p:nvSpPr>
+          <p:cNvPr id="21" name="Rectangle 20"/>
+          <p:cNvSpPr/>
+          <p:nvPr/>
+        </p:nvSpPr>
+        <p:spPr>
+          <a:xfrm>
+            <a:off x="457200" y="3749039"/>
+            <a:ext cx="11274552" cy="475488"/>
+          </a:xfrm>
+          <a:prstGeom prst="rect">
+            <a:avLst/>
+          </a:prstGeom>
+          <a:solidFill>
+            <a:srgbClr val="F8FAFC"/>
+          </a:solidFill>
+          <a:ln>
+            <a:noFill/>
+          </a:ln>
+        </p:spPr>
+        <p:style>
+          <a:lnRef idx="1">
+            <a:schemeClr val="accent1"/>
+          </a:lnRef>
+          <a:fillRef idx="3">
+            <a:schemeClr val="accent1"/>
+          </a:fillRef>
+          <a:effectRef idx="2">
+            <a:schemeClr val="accent1"/>
+          </a:effectRef>
+          <a:fontRef idx="minor">
+            <a:schemeClr val="lt1"/>
+          </a:fontRef>
+        </p:style>
+        <p:txBody>
+          <a:bodyPr rtlCol="0" anchor="ctr"/>
+          <a:lstStyle/>
+          <a:p>
+            <a:pPr algn="ctr"/>
+          </a:p>
+        </p:txBody>
+      </p:sp>
+      <p:sp>
+        <p:nvSpPr>
+          <p:cNvPr id="22" name="TextBox 21"/>
+          <p:cNvSpPr txBox="1"/>
+          <p:nvPr/>
+        </p:nvSpPr>
+        <p:spPr>
+          <a:xfrm>
+            <a:off x="621792" y="3822191"/>
+            <a:ext cx="10972800" cy="329184"/>
+          </a:xfrm>
+          <a:prstGeom prst="rect">
+            <a:avLst/>
+          </a:prstGeom>
+          <a:noFill/>
+        </p:spPr>
+        <p:txBody>
+          <a:bodyPr wrap="square">
+            <a:spAutoFit/>
+          </a:bodyPr>
+          <a:lstStyle/>
+          <a:p>
+            <a:pPr algn="l"/>
+            <a:r>
+              <a:rPr sz="1500" b="1" i="0">
+                <a:solidFill>
+                  <a:srgbClr val="1A222E"/>
+                </a:solidFill>
+              </a:rPr>
+              <a:t>Code Agent 的收益是真的，但前提是：任務描述清楚 + 驗證結果的成本夠低</a:t>
+            </a:r>
+          </a:p>
+        </p:txBody>
+      </p:sp>
+    </p:spTree>
+  </p:cSld>
+  <p:clrMapOvr>
+    <a:masterClrMapping/>
+  </p:clrMapOvr>
+</p:sld>
+</file>
+
+<file path=ppt/slides/slide25.xml><?xml version="1.0" encoding="utf-8"?>
 <p:sld xmlns:a="http://schemas.openxmlformats.org/drawingml/2006/main" xmlns:p="http://schemas.openxmlformats.org/presentationml/2006/main" xmlns:r="http://schemas.openxmlformats.org/officeDocument/2006/relationships">
   <p:cSld>
     <p:bg>

</xml_diff>

<commit_message>
feat: Update tool concurrency explanation and settings
Refine the documentation and presentation slides to accurately reflect tool concurrency behavior.

This commit updates:
- `.claude/settings.local.json`: Adds `Bash(git:*)` to allowed tools.
- `claude_code_full.pptx`: Updates slide content regarding tool execution, specifically differentiating between read-only and write tools concerning concurrency.
- `make_combined_ppt.py`: Modifies the script to update the PPT slide content related to tool concurrency details.
- `tools.md`: Adds a new section detailing `isConcurrencySafe` flag, explaining how it affects parallel versus sequential execution of tools based on their read/write nature. Includes practical verification and API-level control.

The changes clarify how different types of tools (read-only vs. write) interact with the framework's concurrency mechanisms, providing a more precise understanding of parallel tool execution.
</commit_message>
<xml_diff>
--- a/claude_code_full.pptx
+++ b/claude_code_full.pptx
@@ -4206,22 +4206,22 @@
         <p:spPr>
           <a:xfrm>
             <a:off x="502920" y="2450592"/>
-            <a:ext cx="11155680" cy="457200"/>
-          </a:xfrm>
-          <a:prstGeom prst="rect">
-            <a:avLst/>
-          </a:prstGeom>
-          <a:noFill/>
-        </p:spPr>
-        <p:txBody>
-          <a:bodyPr wrap="square">
-            <a:spAutoFit/>
-          </a:bodyPr>
-          <a:lstStyle/>
-          <a:p>
-            <a:pPr algn="l"/>
-            <a:r>
-              <a:rPr sz="1700" b="0" i="0">
+            <a:ext cx="11155680" cy="420624"/>
+          </a:xfrm>
+          <a:prstGeom prst="rect">
+            <a:avLst/>
+          </a:prstGeom>
+          <a:noFill/>
+        </p:spPr>
+        <p:txBody>
+          <a:bodyPr wrap="square">
+            <a:spAutoFit/>
+          </a:bodyPr>
+          <a:lstStyle/>
+          <a:p>
+            <a:pPr algn="l"/>
+            <a:r>
+              <a:rPr sz="1600" b="0" i="0">
                 <a:solidFill>
                   <a:srgbClr val="1A222E"/>
                 </a:solidFill>
@@ -4239,28 +4239,28 @@
         </p:nvSpPr>
         <p:spPr>
           <a:xfrm>
-            <a:off x="502920" y="2907792"/>
-            <a:ext cx="11155680" cy="457200"/>
-          </a:xfrm>
-          <a:prstGeom prst="rect">
-            <a:avLst/>
-          </a:prstGeom>
-          <a:noFill/>
-        </p:spPr>
-        <p:txBody>
-          <a:bodyPr wrap="square">
-            <a:spAutoFit/>
-          </a:bodyPr>
-          <a:lstStyle/>
-          <a:p>
-            <a:pPr algn="l"/>
-            <a:r>
-              <a:rPr sz="1700" b="0" i="0">
+            <a:off x="502920" y="2871216"/>
+            <a:ext cx="11155680" cy="420624"/>
+          </a:xfrm>
+          <a:prstGeom prst="rect">
+            <a:avLst/>
+          </a:prstGeom>
+          <a:noFill/>
+        </p:spPr>
+        <p:txBody>
+          <a:bodyPr wrap="square">
+            <a:spAutoFit/>
+          </a:bodyPr>
+          <a:lstStyle/>
+          <a:p>
+            <a:pPr algn="l"/>
+            <a:r>
+              <a:rPr sz="1600" b="0" i="0">
                 <a:solidFill>
                   <a:srgbClr val="1A222E"/>
                 </a:solidFill>
               </a:rPr>
-              <a:t>• 多個 tool_use 批次發出 → 平行執行 → 所有結果一起回來 → 才進行下一次推理</a:t>
+              <a:t>• 多個 tool_use 批次發出 → 所有結果一起回來 → 才進行下一次推理</a:t>
             </a:r>
           </a:p>
         </p:txBody>
@@ -4273,23 +4273,91 @@
         </p:nvSpPr>
         <p:spPr>
           <a:xfrm>
-            <a:off x="502920" y="3364992"/>
-            <a:ext cx="11155680" cy="457200"/>
-          </a:xfrm>
-          <a:prstGeom prst="rect">
-            <a:avLst/>
-          </a:prstGeom>
-          <a:noFill/>
-        </p:spPr>
-        <p:txBody>
-          <a:bodyPr wrap="square">
-            <a:spAutoFit/>
-          </a:bodyPr>
-          <a:lstStyle/>
-          <a:p>
-            <a:pPr algn="l"/>
-            <a:r>
-              <a:rPr sz="1700" b="0" i="0">
+            <a:off x="502920" y="3291840"/>
+            <a:ext cx="11155680" cy="420624"/>
+          </a:xfrm>
+          <a:prstGeom prst="rect">
+            <a:avLst/>
+          </a:prstGeom>
+          <a:noFill/>
+        </p:spPr>
+        <p:txBody>
+          <a:bodyPr wrap="square">
+            <a:spAutoFit/>
+          </a:bodyPr>
+          <a:lstStyle/>
+          <a:p>
+            <a:pPr algn="l"/>
+            <a:r>
+              <a:rPr sz="1400" b="0" i="0">
+                <a:solidFill>
+                  <a:srgbClr val="55657A"/>
+                </a:solidFill>
+              </a:rPr>
+              <a:t>    • 唯讀工具（Read / Glob / Grep）isConcurrencySafe=true → 真正平行執行（binary 實測）</a:t>
+            </a:r>
+          </a:p>
+        </p:txBody>
+      </p:sp>
+      <p:sp>
+        <p:nvSpPr>
+          <p:cNvPr id="27" name="TextBox 26"/>
+          <p:cNvSpPr txBox="1"/>
+          <p:nvPr/>
+        </p:nvSpPr>
+        <p:spPr>
+          <a:xfrm>
+            <a:off x="502920" y="3712464"/>
+            <a:ext cx="11155680" cy="420624"/>
+          </a:xfrm>
+          <a:prstGeom prst="rect">
+            <a:avLst/>
+          </a:prstGeom>
+          <a:noFill/>
+        </p:spPr>
+        <p:txBody>
+          <a:bodyPr wrap="square">
+            <a:spAutoFit/>
+          </a:bodyPr>
+          <a:lstStyle/>
+          <a:p>
+            <a:pPr algn="l"/>
+            <a:r>
+              <a:rPr sz="1400" b="0" i="0">
+                <a:solidFill>
+                  <a:srgbClr val="55657A"/>
+                </a:solidFill>
+              </a:rPr>
+              <a:t>    • 寫入工具（Write / Edit 等）isConcurrencySafe=false → 遇到即停，單獨執行後再繼續</a:t>
+            </a:r>
+          </a:p>
+        </p:txBody>
+      </p:sp>
+      <p:sp>
+        <p:nvSpPr>
+          <p:cNvPr id="28" name="TextBox 27"/>
+          <p:cNvSpPr txBox="1"/>
+          <p:nvPr/>
+        </p:nvSpPr>
+        <p:spPr>
+          <a:xfrm>
+            <a:off x="502920" y="4133088"/>
+            <a:ext cx="11155680" cy="420624"/>
+          </a:xfrm>
+          <a:prstGeom prst="rect">
+            <a:avLst/>
+          </a:prstGeom>
+          <a:noFill/>
+        </p:spPr>
+        <p:txBody>
+          <a:bodyPr wrap="square">
+            <a:spAutoFit/>
+          </a:bodyPr>
+          <a:lstStyle/>
+          <a:p>
+            <a:pPr algn="l"/>
+            <a:r>
+              <a:rPr sz="1600" b="0" i="0">
                 <a:solidFill>
                   <a:srgbClr val="1A222E"/>
                 </a:solidFill>
@@ -4301,29 +4369,29 @@
       </p:sp>
       <p:sp>
         <p:nvSpPr>
-          <p:cNvPr id="27" name="TextBox 26"/>
-          <p:cNvSpPr txBox="1"/>
-          <p:nvPr/>
-        </p:nvSpPr>
-        <p:spPr>
-          <a:xfrm>
-            <a:off x="502920" y="3822191"/>
-            <a:ext cx="11155680" cy="457200"/>
-          </a:xfrm>
-          <a:prstGeom prst="rect">
-            <a:avLst/>
-          </a:prstGeom>
-          <a:noFill/>
-        </p:spPr>
-        <p:txBody>
-          <a:bodyPr wrap="square">
-            <a:spAutoFit/>
-          </a:bodyPr>
-          <a:lstStyle/>
-          <a:p>
-            <a:pPr algn="l"/>
-            <a:r>
-              <a:rPr sz="1700" b="0" i="0">
+          <p:cNvPr id="29" name="TextBox 28"/>
+          <p:cNvSpPr txBox="1"/>
+          <p:nvPr/>
+        </p:nvSpPr>
+        <p:spPr>
+          <a:xfrm>
+            <a:off x="502920" y="4553712"/>
+            <a:ext cx="11155680" cy="420624"/>
+          </a:xfrm>
+          <a:prstGeom prst="rect">
+            <a:avLst/>
+          </a:prstGeom>
+          <a:noFill/>
+        </p:spPr>
+        <p:txBody>
+          <a:bodyPr wrap="square">
+            <a:spAutoFit/>
+          </a:bodyPr>
+          <a:lstStyle/>
+          <a:p>
+            <a:pPr algn="l"/>
+            <a:r>
+              <a:rPr sz="1600" b="0" i="0">
                 <a:solidFill>
                   <a:srgbClr val="1A222E"/>
                 </a:solidFill>
@@ -4335,29 +4403,29 @@
       </p:sp>
       <p:sp>
         <p:nvSpPr>
-          <p:cNvPr id="28" name="TextBox 27"/>
-          <p:cNvSpPr txBox="1"/>
-          <p:nvPr/>
-        </p:nvSpPr>
-        <p:spPr>
-          <a:xfrm>
-            <a:off x="502920" y="4279392"/>
-            <a:ext cx="11155680" cy="457200"/>
-          </a:xfrm>
-          <a:prstGeom prst="rect">
-            <a:avLst/>
-          </a:prstGeom>
-          <a:noFill/>
-        </p:spPr>
-        <p:txBody>
-          <a:bodyPr wrap="square">
-            <a:spAutoFit/>
-          </a:bodyPr>
-          <a:lstStyle/>
-          <a:p>
-            <a:pPr algn="l"/>
-            <a:r>
-              <a:rPr sz="1700" b="0" i="0">
+          <p:cNvPr id="30" name="TextBox 29"/>
+          <p:cNvSpPr txBox="1"/>
+          <p:nvPr/>
+        </p:nvSpPr>
+        <p:spPr>
+          <a:xfrm>
+            <a:off x="502920" y="4974336"/>
+            <a:ext cx="11155680" cy="420624"/>
+          </a:xfrm>
+          <a:prstGeom prst="rect">
+            <a:avLst/>
+          </a:prstGeom>
+          <a:noFill/>
+        </p:spPr>
+        <p:txBody>
+          <a:bodyPr wrap="square">
+            <a:spAutoFit/>
+          </a:bodyPr>
+          <a:lstStyle/>
+          <a:p>
+            <a:pPr algn="l"/>
+            <a:r>
+              <a:rPr sz="1600" b="0" i="0">
                 <a:solidFill>
                   <a:srgbClr val="1A222E"/>
                 </a:solidFill>
@@ -16047,7 +16115,7 @@
                   <a:srgbClr val="1A222E"/>
                 </a:solidFill>
               </a:rPr>
-              <a:t>• Claude 先 ToolSearch 載入 Skill schema，再呼叫 Skill("name", args)</a:t>
+              <a:t>• Skill 是預載工具，Claude 可直接呼叫 Skill("name", args)，不需 ToolSearch</a:t>
             </a:r>
           </a:p>
         </p:txBody>

</xml_diff>